<commit_message>
added student ID and github link in presentation
</commit_message>
<xml_diff>
--- a/Canadian_Housing_Price_Index_Presentation.pptx
+++ b/Canadian_Housing_Price_Index_Presentation.pptx
@@ -3181,7 +3181,7 @@
           <a:bodyPr/>
           <a:lstStyle/>
           <a:p>
-            <a:endParaRPr lang="en-CA"/>
+            <a:endParaRPr lang="en-CA" dirty="0"/>
           </a:p>
         </p:txBody>
       </p:sp>
@@ -3257,7 +3257,7 @@
                 <a:ea typeface="Calibri" pitchFamily="34" charset="-122"/>
                 <a:cs typeface="Calibri" pitchFamily="34" charset="-120"/>
               </a:rPr>
-              <a:t>Student ID: </a:t>
+              <a:t>Student ID: 000376834</a:t>
             </a:r>
             <a:endParaRPr lang="en-US" sz="1000" dirty="0"/>
           </a:p>
@@ -5352,6 +5352,14 @@
           <a:bodyPr/>
           <a:lstStyle/>
           <a:p>
+            <a:r>
+              <a:rPr lang="en-US" dirty="0">
+                <a:latin typeface="Calibri" pitchFamily="34" charset="0"/>
+                <a:ea typeface="Calibri" pitchFamily="34" charset="-122"/>
+                <a:cs typeface="Calibri" pitchFamily="34" charset="-120"/>
+              </a:rPr>
+              <a:t>000376834</a:t>
+            </a:r>
             <a:endParaRPr lang="en-CA" dirty="0"/>
           </a:p>
         </p:txBody>
@@ -5983,8 +5991,27 @@
                 <a:ea typeface="Calibri" pitchFamily="34" charset="-122"/>
                 <a:cs typeface="Calibri" pitchFamily="34" charset="-120"/>
               </a:rPr>
-              <a:t>Personal GitHub Repository Link:- </a:t>
-            </a:r>
+              <a:t>Personal GitHub Repository Link</a:t>
+            </a:r>
+            <a:r>
+              <a:rPr lang="en-US" sz="1000" i="1">
+                <a:solidFill>
+                  <a:srgbClr val="94A3B8"/>
+                </a:solidFill>
+                <a:latin typeface="Calibri" pitchFamily="34" charset="0"/>
+                <a:ea typeface="Calibri" pitchFamily="34" charset="-122"/>
+                <a:cs typeface="Calibri" pitchFamily="34" charset="-120"/>
+              </a:rPr>
+              <a:t>:-  https://github.com/yadveerkaur21/final-python2-project</a:t>
+            </a:r>
+            <a:endParaRPr lang="en-US" sz="1000" i="1" dirty="0">
+              <a:solidFill>
+                <a:srgbClr val="94A3B8"/>
+              </a:solidFill>
+              <a:latin typeface="Calibri" pitchFamily="34" charset="0"/>
+              <a:ea typeface="Calibri" pitchFamily="34" charset="-122"/>
+              <a:cs typeface="Calibri" pitchFamily="34" charset="-120"/>
+            </a:endParaRPr>
           </a:p>
           <a:p>
             <a:r>

</xml_diff>